<commit_message>
Subo la nueva presentación con el feedback
</commit_message>
<xml_diff>
--- a/entrega_intermedia/presentacion-intermedia-SocioUnido.pptx
+++ b/entrega_intermedia/presentacion-intermedia-SocioUnido.pptx
@@ -6,29 +6,29 @@
   </p:sldMasterIdLst>
   <p:sldIdLst>
     <p:sldId id="256" r:id="rId2"/>
-    <p:sldId id="257" r:id="rId3"/>
-    <p:sldId id="258" r:id="rId4"/>
-    <p:sldId id="259" r:id="rId5"/>
-    <p:sldId id="260" r:id="rId6"/>
-    <p:sldId id="261" r:id="rId7"/>
-    <p:sldId id="262" r:id="rId8"/>
-    <p:sldId id="263" r:id="rId9"/>
-    <p:sldId id="264" r:id="rId10"/>
-    <p:sldId id="265" r:id="rId11"/>
-    <p:sldId id="266" r:id="rId12"/>
-    <p:sldId id="267" r:id="rId13"/>
-    <p:sldId id="268" r:id="rId14"/>
-    <p:sldId id="269" r:id="rId15"/>
-    <p:sldId id="270" r:id="rId16"/>
-    <p:sldId id="271" r:id="rId17"/>
-    <p:sldId id="272" r:id="rId18"/>
-    <p:sldId id="273" r:id="rId19"/>
-    <p:sldId id="274" r:id="rId20"/>
-    <p:sldId id="275" r:id="rId21"/>
-    <p:sldId id="276" r:id="rId22"/>
-    <p:sldId id="277" r:id="rId23"/>
-    <p:sldId id="278" r:id="rId24"/>
-    <p:sldId id="279" r:id="rId25"/>
+    <p:sldId id="258" r:id="rId3"/>
+    <p:sldId id="259" r:id="rId4"/>
+    <p:sldId id="260" r:id="rId5"/>
+    <p:sldId id="261" r:id="rId6"/>
+    <p:sldId id="262" r:id="rId7"/>
+    <p:sldId id="263" r:id="rId8"/>
+    <p:sldId id="264" r:id="rId9"/>
+    <p:sldId id="265" r:id="rId10"/>
+    <p:sldId id="266" r:id="rId11"/>
+    <p:sldId id="267" r:id="rId12"/>
+    <p:sldId id="268" r:id="rId13"/>
+    <p:sldId id="269" r:id="rId14"/>
+    <p:sldId id="270" r:id="rId15"/>
+    <p:sldId id="271" r:id="rId16"/>
+    <p:sldId id="272" r:id="rId17"/>
+    <p:sldId id="273" r:id="rId18"/>
+    <p:sldId id="274" r:id="rId19"/>
+    <p:sldId id="275" r:id="rId20"/>
+    <p:sldId id="276" r:id="rId21"/>
+    <p:sldId id="277" r:id="rId22"/>
+    <p:sldId id="278" r:id="rId23"/>
+    <p:sldId id="279" r:id="rId24"/>
+    <p:sldId id="257" r:id="rId25"/>
     <p:sldId id="280" r:id="rId26"/>
   </p:sldIdLst>
   <p:sldSz cx="12192000" cy="6858000"/>
@@ -128,6 +128,11 @@
       </a:defRPr>
     </a:lvl9pPr>
   </p:defaultTextStyle>
+  <p:extLst>
+    <p:ext uri="{EFAFB233-063F-42B5-8137-9DF3F51BA10A}">
+      <p15:sldGuideLst xmlns:p15="http://schemas.microsoft.com/office/powerpoint/2012/main"/>
+    </p:ext>
+  </p:extLst>
 </p:presentation>
 </file>
 
@@ -280,7 +285,7 @@
           <a:p>
             <a:fld id="{306FF930-1B1D-4D9D-94F7-484F0D0B4167}" type="datetimeFigureOut">
               <a:rPr lang="es-AR" smtClean="0"/>
-              <a:t>23/6/2026</a:t>
+              <a:t>25/6/2026</a:t>
             </a:fld>
             <a:endParaRPr lang="es-AR"/>
           </a:p>
@@ -334,7 +339,7 @@
           <a:p>
             <a:fld id="{5E747B70-7BF8-4839-B134-BDC359C860DC}" type="slidenum">
               <a:rPr lang="es-AR" smtClean="0"/>
-              <a:t>‹Nº›</a:t>
+              <a:t>‹#›</a:t>
             </a:fld>
             <a:endParaRPr lang="es-AR"/>
           </a:p>
@@ -480,7 +485,7 @@
           <a:p>
             <a:fld id="{306FF930-1B1D-4D9D-94F7-484F0D0B4167}" type="datetimeFigureOut">
               <a:rPr lang="es-AR" smtClean="0"/>
-              <a:t>23/6/2026</a:t>
+              <a:t>25/6/2026</a:t>
             </a:fld>
             <a:endParaRPr lang="es-AR"/>
           </a:p>
@@ -534,7 +539,7 @@
           <a:p>
             <a:fld id="{5E747B70-7BF8-4839-B134-BDC359C860DC}" type="slidenum">
               <a:rPr lang="es-AR" smtClean="0"/>
-              <a:t>‹Nº›</a:t>
+              <a:t>‹#›</a:t>
             </a:fld>
             <a:endParaRPr lang="es-AR"/>
           </a:p>
@@ -690,7 +695,7 @@
           <a:p>
             <a:fld id="{306FF930-1B1D-4D9D-94F7-484F0D0B4167}" type="datetimeFigureOut">
               <a:rPr lang="es-AR" smtClean="0"/>
-              <a:t>23/6/2026</a:t>
+              <a:t>25/6/2026</a:t>
             </a:fld>
             <a:endParaRPr lang="es-AR"/>
           </a:p>
@@ -744,7 +749,7 @@
           <a:p>
             <a:fld id="{5E747B70-7BF8-4839-B134-BDC359C860DC}" type="slidenum">
               <a:rPr lang="es-AR" smtClean="0"/>
-              <a:t>‹Nº›</a:t>
+              <a:t>‹#›</a:t>
             </a:fld>
             <a:endParaRPr lang="es-AR"/>
           </a:p>
@@ -890,7 +895,7 @@
           <a:p>
             <a:fld id="{306FF930-1B1D-4D9D-94F7-484F0D0B4167}" type="datetimeFigureOut">
               <a:rPr lang="es-AR" smtClean="0"/>
-              <a:t>23/6/2026</a:t>
+              <a:t>25/6/2026</a:t>
             </a:fld>
             <a:endParaRPr lang="es-AR"/>
           </a:p>
@@ -944,7 +949,7 @@
           <a:p>
             <a:fld id="{5E747B70-7BF8-4839-B134-BDC359C860DC}" type="slidenum">
               <a:rPr lang="es-AR" smtClean="0"/>
-              <a:t>‹Nº›</a:t>
+              <a:t>‹#›</a:t>
             </a:fld>
             <a:endParaRPr lang="es-AR"/>
           </a:p>
@@ -1166,7 +1171,7 @@
           <a:p>
             <a:fld id="{306FF930-1B1D-4D9D-94F7-484F0D0B4167}" type="datetimeFigureOut">
               <a:rPr lang="es-AR" smtClean="0"/>
-              <a:t>23/6/2026</a:t>
+              <a:t>25/6/2026</a:t>
             </a:fld>
             <a:endParaRPr lang="es-AR"/>
           </a:p>
@@ -1220,7 +1225,7 @@
           <a:p>
             <a:fld id="{5E747B70-7BF8-4839-B134-BDC359C860DC}" type="slidenum">
               <a:rPr lang="es-AR" smtClean="0"/>
-              <a:t>‹Nº›</a:t>
+              <a:t>‹#›</a:t>
             </a:fld>
             <a:endParaRPr lang="es-AR"/>
           </a:p>
@@ -1434,7 +1439,7 @@
           <a:p>
             <a:fld id="{306FF930-1B1D-4D9D-94F7-484F0D0B4167}" type="datetimeFigureOut">
               <a:rPr lang="es-AR" smtClean="0"/>
-              <a:t>23/6/2026</a:t>
+              <a:t>25/6/2026</a:t>
             </a:fld>
             <a:endParaRPr lang="es-AR"/>
           </a:p>
@@ -1488,7 +1493,7 @@
           <a:p>
             <a:fld id="{5E747B70-7BF8-4839-B134-BDC359C860DC}" type="slidenum">
               <a:rPr lang="es-AR" smtClean="0"/>
-              <a:t>‹Nº›</a:t>
+              <a:t>‹#›</a:t>
             </a:fld>
             <a:endParaRPr lang="es-AR"/>
           </a:p>
@@ -1849,7 +1854,7 @@
           <a:p>
             <a:fld id="{306FF930-1B1D-4D9D-94F7-484F0D0B4167}" type="datetimeFigureOut">
               <a:rPr lang="es-AR" smtClean="0"/>
-              <a:t>23/6/2026</a:t>
+              <a:t>25/6/2026</a:t>
             </a:fld>
             <a:endParaRPr lang="es-AR"/>
           </a:p>
@@ -1903,7 +1908,7 @@
           <a:p>
             <a:fld id="{5E747B70-7BF8-4839-B134-BDC359C860DC}" type="slidenum">
               <a:rPr lang="es-AR" smtClean="0"/>
-              <a:t>‹Nº›</a:t>
+              <a:t>‹#›</a:t>
             </a:fld>
             <a:endParaRPr lang="es-AR"/>
           </a:p>
@@ -1991,7 +1996,7 @@
           <a:p>
             <a:fld id="{306FF930-1B1D-4D9D-94F7-484F0D0B4167}" type="datetimeFigureOut">
               <a:rPr lang="es-AR" smtClean="0"/>
-              <a:t>23/6/2026</a:t>
+              <a:t>25/6/2026</a:t>
             </a:fld>
             <a:endParaRPr lang="es-AR"/>
           </a:p>
@@ -2045,7 +2050,7 @@
           <a:p>
             <a:fld id="{5E747B70-7BF8-4839-B134-BDC359C860DC}" type="slidenum">
               <a:rPr lang="es-AR" smtClean="0"/>
-              <a:t>‹Nº›</a:t>
+              <a:t>‹#›</a:t>
             </a:fld>
             <a:endParaRPr lang="es-AR"/>
           </a:p>
@@ -2104,7 +2109,7 @@
           <a:p>
             <a:fld id="{306FF930-1B1D-4D9D-94F7-484F0D0B4167}" type="datetimeFigureOut">
               <a:rPr lang="es-AR" smtClean="0"/>
-              <a:t>23/6/2026</a:t>
+              <a:t>25/6/2026</a:t>
             </a:fld>
             <a:endParaRPr lang="es-AR"/>
           </a:p>
@@ -2158,7 +2163,7 @@
           <a:p>
             <a:fld id="{5E747B70-7BF8-4839-B134-BDC359C860DC}" type="slidenum">
               <a:rPr lang="es-AR" smtClean="0"/>
-              <a:t>‹Nº›</a:t>
+              <a:t>‹#›</a:t>
             </a:fld>
             <a:endParaRPr lang="es-AR"/>
           </a:p>
@@ -2417,7 +2422,7 @@
           <a:p>
             <a:fld id="{306FF930-1B1D-4D9D-94F7-484F0D0B4167}" type="datetimeFigureOut">
               <a:rPr lang="es-AR" smtClean="0"/>
-              <a:t>23/6/2026</a:t>
+              <a:t>25/6/2026</a:t>
             </a:fld>
             <a:endParaRPr lang="es-AR"/>
           </a:p>
@@ -2471,7 +2476,7 @@
           <a:p>
             <a:fld id="{5E747B70-7BF8-4839-B134-BDC359C860DC}" type="slidenum">
               <a:rPr lang="es-AR" smtClean="0"/>
-              <a:t>‹Nº›</a:t>
+              <a:t>‹#›</a:t>
             </a:fld>
             <a:endParaRPr lang="es-AR"/>
           </a:p>
@@ -2706,7 +2711,7 @@
           <a:p>
             <a:fld id="{306FF930-1B1D-4D9D-94F7-484F0D0B4167}" type="datetimeFigureOut">
               <a:rPr lang="es-AR" smtClean="0"/>
-              <a:t>23/6/2026</a:t>
+              <a:t>25/6/2026</a:t>
             </a:fld>
             <a:endParaRPr lang="es-AR"/>
           </a:p>
@@ -2760,7 +2765,7 @@
           <a:p>
             <a:fld id="{5E747B70-7BF8-4839-B134-BDC359C860DC}" type="slidenum">
               <a:rPr lang="es-AR" smtClean="0"/>
-              <a:t>‹Nº›</a:t>
+              <a:t>‹#›</a:t>
             </a:fld>
             <a:endParaRPr lang="es-AR"/>
           </a:p>
@@ -2949,7 +2954,7 @@
           <a:p>
             <a:fld id="{306FF930-1B1D-4D9D-94F7-484F0D0B4167}" type="datetimeFigureOut">
               <a:rPr lang="es-AR" smtClean="0"/>
-              <a:t>23/6/2026</a:t>
+              <a:t>25/6/2026</a:t>
             </a:fld>
             <a:endParaRPr lang="es-AR"/>
           </a:p>
@@ -3039,7 +3044,7 @@
           <a:p>
             <a:fld id="{5E747B70-7BF8-4839-B134-BDC359C860DC}" type="slidenum">
               <a:rPr lang="es-AR" smtClean="0"/>
-              <a:t>‹Nº›</a:t>
+              <a:t>‹#›</a:t>
             </a:fld>
             <a:endParaRPr lang="es-AR"/>
           </a:p>
@@ -3417,72 +3422,6 @@
         <p:cNvPr id="1" name="">
           <a:extLst>
             <a:ext uri="{FF2B5EF4-FFF2-40B4-BE49-F238E27FC236}">
-              <a16:creationId xmlns:a16="http://schemas.microsoft.com/office/drawing/2014/main" id="{7C29125E-EF22-B0FB-EC1C-611DF9C262B3}"/>
-            </a:ext>
-          </a:extLst>
-        </p:cNvPr>
-        <p:cNvGrpSpPr/>
-        <p:nvPr/>
-      </p:nvGrpSpPr>
-      <p:grpSpPr>
-        <a:xfrm>
-          <a:off x="0" y="0"/>
-          <a:ext cx="0" cy="0"/>
-          <a:chOff x="0" y="0"/>
-          <a:chExt cx="0" cy="0"/>
-        </a:xfrm>
-      </p:grpSpPr>
-      <p:pic>
-        <p:nvPicPr>
-          <p:cNvPr id="3" name="Imagen 2">
-            <a:extLst>
-              <a:ext uri="{FF2B5EF4-FFF2-40B4-BE49-F238E27FC236}">
-                <a16:creationId xmlns:a16="http://schemas.microsoft.com/office/drawing/2014/main" id="{CA88DB13-AB86-0353-0DDB-29B62B1BA7F7}"/>
-              </a:ext>
-            </a:extLst>
-          </p:cNvPr>
-          <p:cNvPicPr>
-            <a:picLocks noChangeAspect="1"/>
-          </p:cNvPicPr>
-          <p:nvPr/>
-        </p:nvPicPr>
-        <p:blipFill>
-          <a:blip r:embed="rId2"/>
-          <a:stretch>
-            <a:fillRect/>
-          </a:stretch>
-        </p:blipFill>
-        <p:spPr>
-          <a:xfrm>
-            <a:off x="0" y="0"/>
-            <a:ext cx="12192000" cy="6858000"/>
-          </a:xfrm>
-          <a:prstGeom prst="rect">
-            <a:avLst/>
-          </a:prstGeom>
-        </p:spPr>
-      </p:pic>
-    </p:spTree>
-    <p:extLst>
-      <p:ext uri="{BB962C8B-B14F-4D97-AF65-F5344CB8AC3E}">
-        <p14:creationId xmlns:p14="http://schemas.microsoft.com/office/powerpoint/2010/main" val="2943224096"/>
-      </p:ext>
-    </p:extLst>
-  </p:cSld>
-  <p:clrMapOvr>
-    <a:masterClrMapping/>
-  </p:clrMapOvr>
-</p:sld>
-</file>
-
-<file path=ppt/slides/slide11.xml><?xml version="1.0" encoding="utf-8"?>
-<p:sld xmlns:a="http://schemas.openxmlformats.org/drawingml/2006/main" xmlns:r="http://schemas.openxmlformats.org/officeDocument/2006/relationships" xmlns:p="http://schemas.openxmlformats.org/presentationml/2006/main">
-  <p:cSld>
-    <p:spTree>
-      <p:nvGrpSpPr>
-        <p:cNvPr id="1" name="">
-          <a:extLst>
-            <a:ext uri="{FF2B5EF4-FFF2-40B4-BE49-F238E27FC236}">
               <a16:creationId xmlns:a16="http://schemas.microsoft.com/office/drawing/2014/main" id="{ABE1AC16-E673-69A5-4C30-98A99CA6F8B5}"/>
             </a:ext>
           </a:extLst>
@@ -3541,7 +3480,7 @@
 </p:sld>
 </file>
 
-<file path=ppt/slides/slide12.xml><?xml version="1.0" encoding="utf-8"?>
+<file path=ppt/slides/slide11.xml><?xml version="1.0" encoding="utf-8"?>
 <p:sld xmlns:a="http://schemas.openxmlformats.org/drawingml/2006/main" xmlns:r="http://schemas.openxmlformats.org/officeDocument/2006/relationships" xmlns:p="http://schemas.openxmlformats.org/presentationml/2006/main">
   <p:cSld>
     <p:spTree>
@@ -3607,7 +3546,7 @@
 </p:sld>
 </file>
 
-<file path=ppt/slides/slide13.xml><?xml version="1.0" encoding="utf-8"?>
+<file path=ppt/slides/slide12.xml><?xml version="1.0" encoding="utf-8"?>
 <p:sld xmlns:a="http://schemas.openxmlformats.org/drawingml/2006/main" xmlns:r="http://schemas.openxmlformats.org/officeDocument/2006/relationships" xmlns:p="http://schemas.openxmlformats.org/presentationml/2006/main">
   <p:cSld>
     <p:spTree>
@@ -3673,7 +3612,7 @@
 </p:sld>
 </file>
 
-<file path=ppt/slides/slide14.xml><?xml version="1.0" encoding="utf-8"?>
+<file path=ppt/slides/slide13.xml><?xml version="1.0" encoding="utf-8"?>
 <p:sld xmlns:a="http://schemas.openxmlformats.org/drawingml/2006/main" xmlns:r="http://schemas.openxmlformats.org/officeDocument/2006/relationships" xmlns:p="http://schemas.openxmlformats.org/presentationml/2006/main">
   <p:cSld>
     <p:spTree>
@@ -3739,7 +3678,7 @@
 </p:sld>
 </file>
 
-<file path=ppt/slides/slide15.xml><?xml version="1.0" encoding="utf-8"?>
+<file path=ppt/slides/slide14.xml><?xml version="1.0" encoding="utf-8"?>
 <p:sld xmlns:a="http://schemas.openxmlformats.org/drawingml/2006/main" xmlns:r="http://schemas.openxmlformats.org/officeDocument/2006/relationships" xmlns:p="http://schemas.openxmlformats.org/presentationml/2006/main">
   <p:cSld>
     <p:spTree>
@@ -3805,7 +3744,7 @@
 </p:sld>
 </file>
 
-<file path=ppt/slides/slide16.xml><?xml version="1.0" encoding="utf-8"?>
+<file path=ppt/slides/slide15.xml><?xml version="1.0" encoding="utf-8"?>
 <p:sld xmlns:a="http://schemas.openxmlformats.org/drawingml/2006/main" xmlns:r="http://schemas.openxmlformats.org/officeDocument/2006/relationships" xmlns:p="http://schemas.openxmlformats.org/presentationml/2006/main">
   <p:cSld>
     <p:spTree>
@@ -3871,7 +3810,7 @@
 </p:sld>
 </file>
 
-<file path=ppt/slides/slide17.xml><?xml version="1.0" encoding="utf-8"?>
+<file path=ppt/slides/slide16.xml><?xml version="1.0" encoding="utf-8"?>
 <p:sld xmlns:a="http://schemas.openxmlformats.org/drawingml/2006/main" xmlns:r="http://schemas.openxmlformats.org/officeDocument/2006/relationships" xmlns:p="http://schemas.openxmlformats.org/presentationml/2006/main">
   <p:cSld>
     <p:spTree>
@@ -3937,7 +3876,7 @@
 </p:sld>
 </file>
 
-<file path=ppt/slides/slide18.xml><?xml version="1.0" encoding="utf-8"?>
+<file path=ppt/slides/slide17.xml><?xml version="1.0" encoding="utf-8"?>
 <p:sld xmlns:a="http://schemas.openxmlformats.org/drawingml/2006/main" xmlns:r="http://schemas.openxmlformats.org/officeDocument/2006/relationships" xmlns:p="http://schemas.openxmlformats.org/presentationml/2006/main">
   <p:cSld>
     <p:spTree>
@@ -4003,7 +3942,7 @@
 </p:sld>
 </file>
 
-<file path=ppt/slides/slide19.xml><?xml version="1.0" encoding="utf-8"?>
+<file path=ppt/slides/slide18.xml><?xml version="1.0" encoding="utf-8"?>
 <p:sld xmlns:a="http://schemas.openxmlformats.org/drawingml/2006/main" xmlns:r="http://schemas.openxmlformats.org/officeDocument/2006/relationships" xmlns:p="http://schemas.openxmlformats.org/presentationml/2006/main">
   <p:cSld>
     <p:spTree>
@@ -4069,73 +4008,7 @@
 </p:sld>
 </file>
 
-<file path=ppt/slides/slide2.xml><?xml version="1.0" encoding="utf-8"?>
-<p:sld xmlns:a="http://schemas.openxmlformats.org/drawingml/2006/main" xmlns:r="http://schemas.openxmlformats.org/officeDocument/2006/relationships" xmlns:p="http://schemas.openxmlformats.org/presentationml/2006/main">
-  <p:cSld>
-    <p:spTree>
-      <p:nvGrpSpPr>
-        <p:cNvPr id="1" name="">
-          <a:extLst>
-            <a:ext uri="{FF2B5EF4-FFF2-40B4-BE49-F238E27FC236}">
-              <a16:creationId xmlns:a16="http://schemas.microsoft.com/office/drawing/2014/main" id="{899E9E5D-0456-0DB6-4E60-A589E40854C5}"/>
-            </a:ext>
-          </a:extLst>
-        </p:cNvPr>
-        <p:cNvGrpSpPr/>
-        <p:nvPr/>
-      </p:nvGrpSpPr>
-      <p:grpSpPr>
-        <a:xfrm>
-          <a:off x="0" y="0"/>
-          <a:ext cx="0" cy="0"/>
-          <a:chOff x="0" y="0"/>
-          <a:chExt cx="0" cy="0"/>
-        </a:xfrm>
-      </p:grpSpPr>
-      <p:pic>
-        <p:nvPicPr>
-          <p:cNvPr id="3" name="Imagen 2">
-            <a:extLst>
-              <a:ext uri="{FF2B5EF4-FFF2-40B4-BE49-F238E27FC236}">
-                <a16:creationId xmlns:a16="http://schemas.microsoft.com/office/drawing/2014/main" id="{EA5B3FF0-38B8-51CC-F0BF-4B80582FE735}"/>
-              </a:ext>
-            </a:extLst>
-          </p:cNvPr>
-          <p:cNvPicPr>
-            <a:picLocks noChangeAspect="1"/>
-          </p:cNvPicPr>
-          <p:nvPr/>
-        </p:nvPicPr>
-        <p:blipFill>
-          <a:blip r:embed="rId2"/>
-          <a:stretch>
-            <a:fillRect/>
-          </a:stretch>
-        </p:blipFill>
-        <p:spPr>
-          <a:xfrm>
-            <a:off x="0" y="0"/>
-            <a:ext cx="12192000" cy="6857999"/>
-          </a:xfrm>
-          <a:prstGeom prst="rect">
-            <a:avLst/>
-          </a:prstGeom>
-        </p:spPr>
-      </p:pic>
-    </p:spTree>
-    <p:extLst>
-      <p:ext uri="{BB962C8B-B14F-4D97-AF65-F5344CB8AC3E}">
-        <p14:creationId xmlns:p14="http://schemas.microsoft.com/office/powerpoint/2010/main" val="2662152632"/>
-      </p:ext>
-    </p:extLst>
-  </p:cSld>
-  <p:clrMapOvr>
-    <a:masterClrMapping/>
-  </p:clrMapOvr>
-</p:sld>
-</file>
-
-<file path=ppt/slides/slide20.xml><?xml version="1.0" encoding="utf-8"?>
+<file path=ppt/slides/slide19.xml><?xml version="1.0" encoding="utf-8"?>
 <p:sld xmlns:a="http://schemas.openxmlformats.org/drawingml/2006/main" xmlns:r="http://schemas.openxmlformats.org/officeDocument/2006/relationships" xmlns:p="http://schemas.openxmlformats.org/presentationml/2006/main">
   <p:cSld>
     <p:spTree>
@@ -4201,7 +4074,73 @@
 </p:sld>
 </file>
 
-<file path=ppt/slides/slide21.xml><?xml version="1.0" encoding="utf-8"?>
+<file path=ppt/slides/slide2.xml><?xml version="1.0" encoding="utf-8"?>
+<p:sld xmlns:a="http://schemas.openxmlformats.org/drawingml/2006/main" xmlns:r="http://schemas.openxmlformats.org/officeDocument/2006/relationships" xmlns:p="http://schemas.openxmlformats.org/presentationml/2006/main">
+  <p:cSld>
+    <p:spTree>
+      <p:nvGrpSpPr>
+        <p:cNvPr id="1" name="">
+          <a:extLst>
+            <a:ext uri="{FF2B5EF4-FFF2-40B4-BE49-F238E27FC236}">
+              <a16:creationId xmlns:a16="http://schemas.microsoft.com/office/drawing/2014/main" id="{8B3BA40A-4CA8-90FA-495E-B93F5461B1AD}"/>
+            </a:ext>
+          </a:extLst>
+        </p:cNvPr>
+        <p:cNvGrpSpPr/>
+        <p:nvPr/>
+      </p:nvGrpSpPr>
+      <p:grpSpPr>
+        <a:xfrm>
+          <a:off x="0" y="0"/>
+          <a:ext cx="0" cy="0"/>
+          <a:chOff x="0" y="0"/>
+          <a:chExt cx="0" cy="0"/>
+        </a:xfrm>
+      </p:grpSpPr>
+      <p:pic>
+        <p:nvPicPr>
+          <p:cNvPr id="3" name="Imagen 2">
+            <a:extLst>
+              <a:ext uri="{FF2B5EF4-FFF2-40B4-BE49-F238E27FC236}">
+                <a16:creationId xmlns:a16="http://schemas.microsoft.com/office/drawing/2014/main" id="{1BE8E76A-1FC4-D511-9024-FF0F48502286}"/>
+              </a:ext>
+            </a:extLst>
+          </p:cNvPr>
+          <p:cNvPicPr>
+            <a:picLocks noChangeAspect="1"/>
+          </p:cNvPicPr>
+          <p:nvPr/>
+        </p:nvPicPr>
+        <p:blipFill>
+          <a:blip r:embed="rId2"/>
+          <a:stretch>
+            <a:fillRect/>
+          </a:stretch>
+        </p:blipFill>
+        <p:spPr>
+          <a:xfrm>
+            <a:off x="0" y="0"/>
+            <a:ext cx="12192000" cy="6858000"/>
+          </a:xfrm>
+          <a:prstGeom prst="rect">
+            <a:avLst/>
+          </a:prstGeom>
+        </p:spPr>
+      </p:pic>
+    </p:spTree>
+    <p:extLst>
+      <p:ext uri="{BB962C8B-B14F-4D97-AF65-F5344CB8AC3E}">
+        <p14:creationId xmlns:p14="http://schemas.microsoft.com/office/powerpoint/2010/main" val="1471351432"/>
+      </p:ext>
+    </p:extLst>
+  </p:cSld>
+  <p:clrMapOvr>
+    <a:masterClrMapping/>
+  </p:clrMapOvr>
+</p:sld>
+</file>
+
+<file path=ppt/slides/slide20.xml><?xml version="1.0" encoding="utf-8"?>
 <p:sld xmlns:a="http://schemas.openxmlformats.org/drawingml/2006/main" xmlns:r="http://schemas.openxmlformats.org/officeDocument/2006/relationships" xmlns:p="http://schemas.openxmlformats.org/presentationml/2006/main">
   <p:cSld>
     <p:spTree>
@@ -4267,7 +4206,7 @@
 </p:sld>
 </file>
 
-<file path=ppt/slides/slide22.xml><?xml version="1.0" encoding="utf-8"?>
+<file path=ppt/slides/slide21.xml><?xml version="1.0" encoding="utf-8"?>
 <p:sld xmlns:a="http://schemas.openxmlformats.org/drawingml/2006/main" xmlns:r="http://schemas.openxmlformats.org/officeDocument/2006/relationships" xmlns:p="http://schemas.openxmlformats.org/presentationml/2006/main">
   <p:cSld>
     <p:spTree>
@@ -4333,7 +4272,7 @@
 </p:sld>
 </file>
 
-<file path=ppt/slides/slide23.xml><?xml version="1.0" encoding="utf-8"?>
+<file path=ppt/slides/slide22.xml><?xml version="1.0" encoding="utf-8"?>
 <p:sld xmlns:a="http://schemas.openxmlformats.org/drawingml/2006/main" xmlns:r="http://schemas.openxmlformats.org/officeDocument/2006/relationships" xmlns:p="http://schemas.openxmlformats.org/presentationml/2006/main">
   <p:cSld>
     <p:spTree>
@@ -4399,7 +4338,7 @@
 </p:sld>
 </file>
 
-<file path=ppt/slides/slide24.xml><?xml version="1.0" encoding="utf-8"?>
+<file path=ppt/slides/slide23.xml><?xml version="1.0" encoding="utf-8"?>
 <p:sld xmlns:a="http://schemas.openxmlformats.org/drawingml/2006/main" xmlns:r="http://schemas.openxmlformats.org/officeDocument/2006/relationships" xmlns:p="http://schemas.openxmlformats.org/presentationml/2006/main">
   <p:cSld>
     <p:spTree>
@@ -4456,6 +4395,72 @@
     <p:extLst>
       <p:ext uri="{BB962C8B-B14F-4D97-AF65-F5344CB8AC3E}">
         <p14:creationId xmlns:p14="http://schemas.microsoft.com/office/powerpoint/2010/main" val="3189470487"/>
+      </p:ext>
+    </p:extLst>
+  </p:cSld>
+  <p:clrMapOvr>
+    <a:masterClrMapping/>
+  </p:clrMapOvr>
+</p:sld>
+</file>
+
+<file path=ppt/slides/slide24.xml><?xml version="1.0" encoding="utf-8"?>
+<p:sld xmlns:a="http://schemas.openxmlformats.org/drawingml/2006/main" xmlns:r="http://schemas.openxmlformats.org/officeDocument/2006/relationships" xmlns:p="http://schemas.openxmlformats.org/presentationml/2006/main">
+  <p:cSld>
+    <p:spTree>
+      <p:nvGrpSpPr>
+        <p:cNvPr id="1" name="">
+          <a:extLst>
+            <a:ext uri="{FF2B5EF4-FFF2-40B4-BE49-F238E27FC236}">
+              <a16:creationId xmlns:a16="http://schemas.microsoft.com/office/drawing/2014/main" id="{899E9E5D-0456-0DB6-4E60-A589E40854C5}"/>
+            </a:ext>
+          </a:extLst>
+        </p:cNvPr>
+        <p:cNvGrpSpPr/>
+        <p:nvPr/>
+      </p:nvGrpSpPr>
+      <p:grpSpPr>
+        <a:xfrm>
+          <a:off x="0" y="0"/>
+          <a:ext cx="0" cy="0"/>
+          <a:chOff x="0" y="0"/>
+          <a:chExt cx="0" cy="0"/>
+        </a:xfrm>
+      </p:grpSpPr>
+      <p:pic>
+        <p:nvPicPr>
+          <p:cNvPr id="3" name="Imagen 2">
+            <a:extLst>
+              <a:ext uri="{FF2B5EF4-FFF2-40B4-BE49-F238E27FC236}">
+                <a16:creationId xmlns:a16="http://schemas.microsoft.com/office/drawing/2014/main" id="{EA5B3FF0-38B8-51CC-F0BF-4B80582FE735}"/>
+              </a:ext>
+            </a:extLst>
+          </p:cNvPr>
+          <p:cNvPicPr>
+            <a:picLocks noChangeAspect="1"/>
+          </p:cNvPicPr>
+          <p:nvPr/>
+        </p:nvPicPr>
+        <p:blipFill>
+          <a:blip r:embed="rId2"/>
+          <a:stretch>
+            <a:fillRect/>
+          </a:stretch>
+        </p:blipFill>
+        <p:spPr>
+          <a:xfrm>
+            <a:off x="0" y="0"/>
+            <a:ext cx="12192000" cy="6857999"/>
+          </a:xfrm>
+          <a:prstGeom prst="rect">
+            <a:avLst/>
+          </a:prstGeom>
+        </p:spPr>
+      </p:pic>
+    </p:spTree>
+    <p:extLst>
+      <p:ext uri="{BB962C8B-B14F-4D97-AF65-F5344CB8AC3E}">
+        <p14:creationId xmlns:p14="http://schemas.microsoft.com/office/powerpoint/2010/main" val="2662152632"/>
       </p:ext>
     </p:extLst>
   </p:cSld>
@@ -4539,72 +4544,6 @@
         <p:cNvPr id="1" name="">
           <a:extLst>
             <a:ext uri="{FF2B5EF4-FFF2-40B4-BE49-F238E27FC236}">
-              <a16:creationId xmlns:a16="http://schemas.microsoft.com/office/drawing/2014/main" id="{8B3BA40A-4CA8-90FA-495E-B93F5461B1AD}"/>
-            </a:ext>
-          </a:extLst>
-        </p:cNvPr>
-        <p:cNvGrpSpPr/>
-        <p:nvPr/>
-      </p:nvGrpSpPr>
-      <p:grpSpPr>
-        <a:xfrm>
-          <a:off x="0" y="0"/>
-          <a:ext cx="0" cy="0"/>
-          <a:chOff x="0" y="0"/>
-          <a:chExt cx="0" cy="0"/>
-        </a:xfrm>
-      </p:grpSpPr>
-      <p:pic>
-        <p:nvPicPr>
-          <p:cNvPr id="3" name="Imagen 2">
-            <a:extLst>
-              <a:ext uri="{FF2B5EF4-FFF2-40B4-BE49-F238E27FC236}">
-                <a16:creationId xmlns:a16="http://schemas.microsoft.com/office/drawing/2014/main" id="{1BE8E76A-1FC4-D511-9024-FF0F48502286}"/>
-              </a:ext>
-            </a:extLst>
-          </p:cNvPr>
-          <p:cNvPicPr>
-            <a:picLocks noChangeAspect="1"/>
-          </p:cNvPicPr>
-          <p:nvPr/>
-        </p:nvPicPr>
-        <p:blipFill>
-          <a:blip r:embed="rId2"/>
-          <a:stretch>
-            <a:fillRect/>
-          </a:stretch>
-        </p:blipFill>
-        <p:spPr>
-          <a:xfrm>
-            <a:off x="0" y="0"/>
-            <a:ext cx="12192000" cy="6858000"/>
-          </a:xfrm>
-          <a:prstGeom prst="rect">
-            <a:avLst/>
-          </a:prstGeom>
-        </p:spPr>
-      </p:pic>
-    </p:spTree>
-    <p:extLst>
-      <p:ext uri="{BB962C8B-B14F-4D97-AF65-F5344CB8AC3E}">
-        <p14:creationId xmlns:p14="http://schemas.microsoft.com/office/powerpoint/2010/main" val="1471351432"/>
-      </p:ext>
-    </p:extLst>
-  </p:cSld>
-  <p:clrMapOvr>
-    <a:masterClrMapping/>
-  </p:clrMapOvr>
-</p:sld>
-</file>
-
-<file path=ppt/slides/slide4.xml><?xml version="1.0" encoding="utf-8"?>
-<p:sld xmlns:a="http://schemas.openxmlformats.org/drawingml/2006/main" xmlns:r="http://schemas.openxmlformats.org/officeDocument/2006/relationships" xmlns:p="http://schemas.openxmlformats.org/presentationml/2006/main">
-  <p:cSld>
-    <p:spTree>
-      <p:nvGrpSpPr>
-        <p:cNvPr id="1" name="">
-          <a:extLst>
-            <a:ext uri="{FF2B5EF4-FFF2-40B4-BE49-F238E27FC236}">
               <a16:creationId xmlns:a16="http://schemas.microsoft.com/office/drawing/2014/main" id="{8F7D809C-D64B-F325-1588-A0112CC3BD52}"/>
             </a:ext>
           </a:extLst>
@@ -4663,7 +4602,7 @@
 </p:sld>
 </file>
 
-<file path=ppt/slides/slide5.xml><?xml version="1.0" encoding="utf-8"?>
+<file path=ppt/slides/slide4.xml><?xml version="1.0" encoding="utf-8"?>
 <p:sld xmlns:a="http://schemas.openxmlformats.org/drawingml/2006/main" xmlns:r="http://schemas.openxmlformats.org/officeDocument/2006/relationships" xmlns:p="http://schemas.openxmlformats.org/presentationml/2006/main">
   <p:cSld>
     <p:spTree>
@@ -4729,7 +4668,7 @@
 </p:sld>
 </file>
 
-<file path=ppt/slides/slide6.xml><?xml version="1.0" encoding="utf-8"?>
+<file path=ppt/slides/slide5.xml><?xml version="1.0" encoding="utf-8"?>
 <p:sld xmlns:a="http://schemas.openxmlformats.org/drawingml/2006/main" xmlns:r="http://schemas.openxmlformats.org/officeDocument/2006/relationships" xmlns:p="http://schemas.openxmlformats.org/presentationml/2006/main">
   <p:cSld>
     <p:spTree>
@@ -4795,7 +4734,7 @@
 </p:sld>
 </file>
 
-<file path=ppt/slides/slide7.xml><?xml version="1.0" encoding="utf-8"?>
+<file path=ppt/slides/slide6.xml><?xml version="1.0" encoding="utf-8"?>
 <p:sld xmlns:a="http://schemas.openxmlformats.org/drawingml/2006/main" xmlns:r="http://schemas.openxmlformats.org/officeDocument/2006/relationships" xmlns:p="http://schemas.openxmlformats.org/presentationml/2006/main">
   <p:cSld>
     <p:spTree>
@@ -4861,7 +4800,7 @@
 </p:sld>
 </file>
 
-<file path=ppt/slides/slide8.xml><?xml version="1.0" encoding="utf-8"?>
+<file path=ppt/slides/slide7.xml><?xml version="1.0" encoding="utf-8"?>
 <p:sld xmlns:a="http://schemas.openxmlformats.org/drawingml/2006/main" xmlns:r="http://schemas.openxmlformats.org/officeDocument/2006/relationships" xmlns:p="http://schemas.openxmlformats.org/presentationml/2006/main">
   <p:cSld>
     <p:spTree>
@@ -4927,7 +4866,7 @@
 </p:sld>
 </file>
 
-<file path=ppt/slides/slide9.xml><?xml version="1.0" encoding="utf-8"?>
+<file path=ppt/slides/slide8.xml><?xml version="1.0" encoding="utf-8"?>
 <p:sld xmlns:a="http://schemas.openxmlformats.org/drawingml/2006/main" xmlns:r="http://schemas.openxmlformats.org/officeDocument/2006/relationships" xmlns:p="http://schemas.openxmlformats.org/presentationml/2006/main">
   <p:cSld>
     <p:spTree>
@@ -4984,6 +4923,72 @@
     <p:extLst>
       <p:ext uri="{BB962C8B-B14F-4D97-AF65-F5344CB8AC3E}">
         <p14:creationId xmlns:p14="http://schemas.microsoft.com/office/powerpoint/2010/main" val="3643563939"/>
+      </p:ext>
+    </p:extLst>
+  </p:cSld>
+  <p:clrMapOvr>
+    <a:masterClrMapping/>
+  </p:clrMapOvr>
+</p:sld>
+</file>
+
+<file path=ppt/slides/slide9.xml><?xml version="1.0" encoding="utf-8"?>
+<p:sld xmlns:a="http://schemas.openxmlformats.org/drawingml/2006/main" xmlns:r="http://schemas.openxmlformats.org/officeDocument/2006/relationships" xmlns:p="http://schemas.openxmlformats.org/presentationml/2006/main">
+  <p:cSld>
+    <p:spTree>
+      <p:nvGrpSpPr>
+        <p:cNvPr id="1" name="">
+          <a:extLst>
+            <a:ext uri="{FF2B5EF4-FFF2-40B4-BE49-F238E27FC236}">
+              <a16:creationId xmlns:a16="http://schemas.microsoft.com/office/drawing/2014/main" id="{7C29125E-EF22-B0FB-EC1C-611DF9C262B3}"/>
+            </a:ext>
+          </a:extLst>
+        </p:cNvPr>
+        <p:cNvGrpSpPr/>
+        <p:nvPr/>
+      </p:nvGrpSpPr>
+      <p:grpSpPr>
+        <a:xfrm>
+          <a:off x="0" y="0"/>
+          <a:ext cx="0" cy="0"/>
+          <a:chOff x="0" y="0"/>
+          <a:chExt cx="0" cy="0"/>
+        </a:xfrm>
+      </p:grpSpPr>
+      <p:pic>
+        <p:nvPicPr>
+          <p:cNvPr id="3" name="Imagen 2">
+            <a:extLst>
+              <a:ext uri="{FF2B5EF4-FFF2-40B4-BE49-F238E27FC236}">
+                <a16:creationId xmlns:a16="http://schemas.microsoft.com/office/drawing/2014/main" id="{CA88DB13-AB86-0353-0DDB-29B62B1BA7F7}"/>
+              </a:ext>
+            </a:extLst>
+          </p:cNvPr>
+          <p:cNvPicPr>
+            <a:picLocks noChangeAspect="1"/>
+          </p:cNvPicPr>
+          <p:nvPr/>
+        </p:nvPicPr>
+        <p:blipFill>
+          <a:blip r:embed="rId2"/>
+          <a:stretch>
+            <a:fillRect/>
+          </a:stretch>
+        </p:blipFill>
+        <p:spPr>
+          <a:xfrm>
+            <a:off x="0" y="0"/>
+            <a:ext cx="12192000" cy="6858000"/>
+          </a:xfrm>
+          <a:prstGeom prst="rect">
+            <a:avLst/>
+          </a:prstGeom>
+        </p:spPr>
+      </p:pic>
+    </p:spTree>
+    <p:extLst>
+      <p:ext uri="{BB962C8B-B14F-4D97-AF65-F5344CB8AC3E}">
+        <p14:creationId xmlns:p14="http://schemas.microsoft.com/office/powerpoint/2010/main" val="2943224096"/>
       </p:ext>
     </p:extLst>
   </p:cSld>

</xml_diff>